<commit_message>
Show V1 / V2 / Effect changes in report, deck and notebook
Section 0 of the report, deck slide 3 and the notebook header now use the
same V1 / V2 / Effect table as the README.

Co-Authored-By: Claude Opus 5.5 <noreply@anthropic.com>
</commit_message>
<xml_diff>
--- a/crypto_stat_arb_deck_V2.pptx
+++ b/crypto_stat_arb_deck_V2.pptx
@@ -3349,7 +3349,7 @@
                 </a:solidFill>
                 <a:latin typeface="Calibri"/>
               </a:rPr>
-              <a:t>Momentum and reversal on a survivorship-free 39-coin universe, revised after trainer feedback</a:t>
+              <a:t>Momentum and reversal on a survivorship-free 39-coin universe</a:t>
             </a:r>
           </a:p>
         </p:txBody>
@@ -18576,7 +18576,7 @@
                 </a:solidFill>
                 <a:latin typeface="Cambria"/>
               </a:rPr>
-              <a:t>What the trainer asked for, and what changed</a:t>
+              <a:t>What changed from V1 to V2</a:t>
             </a:r>
           </a:p>
         </p:txBody>
@@ -18590,7 +18590,7 @@
         <p:spPr>
           <a:xfrm>
             <a:off x="640080" y="1737360"/>
-            <a:ext cx="2743200" cy="685800"/>
+            <a:ext cx="3291840" cy="685800"/>
           </a:xfrm>
           <a:prstGeom prst="rect">
             <a:avLst/>
@@ -18634,7 +18634,7 @@
         <p:spPr>
           <a:xfrm>
             <a:off x="749808" y="1737360"/>
-            <a:ext cx="2633472" cy="685800"/>
+            <a:ext cx="3182112" cy="685800"/>
           </a:xfrm>
           <a:prstGeom prst="rect">
             <a:avLst/>
@@ -18665,7 +18665,7 @@
                 </a:solidFill>
                 <a:latin typeface="Calibri"/>
               </a:rPr>
-              <a:t>Feedback</a:t>
+              <a:t>V1</a:t>
             </a:r>
           </a:p>
         </p:txBody>
@@ -18678,8 +18678,8 @@
         </p:nvSpPr>
         <p:spPr>
           <a:xfrm>
-            <a:off x="3383280" y="1737360"/>
-            <a:ext cx="4480560" cy="685800"/>
+            <a:off x="3931920" y="1737360"/>
+            <a:ext cx="4206240" cy="685800"/>
           </a:xfrm>
           <a:prstGeom prst="rect">
             <a:avLst/>
@@ -18722,8 +18722,8 @@
         </p:nvSpPr>
         <p:spPr>
           <a:xfrm>
-            <a:off x="3383280" y="1737360"/>
-            <a:ext cx="4480560" cy="685800"/>
+            <a:off x="3931920" y="1737360"/>
+            <a:ext cx="4206240" cy="685800"/>
           </a:xfrm>
           <a:prstGeom prst="rect">
             <a:avLst/>
@@ -18754,7 +18754,7 @@
                 </a:solidFill>
                 <a:latin typeface="Calibri"/>
               </a:rPr>
-              <a:t>Version 2 change</a:t>
+              <a:t>V2</a:t>
             </a:r>
           </a:p>
         </p:txBody>
@@ -18767,8 +18767,8 @@
         </p:nvSpPr>
         <p:spPr>
           <a:xfrm>
-            <a:off x="7863840" y="1737360"/>
-            <a:ext cx="3657600" cy="685800"/>
+            <a:off x="8138159" y="1737360"/>
+            <a:ext cx="3383280" cy="685800"/>
           </a:xfrm>
           <a:prstGeom prst="rect">
             <a:avLst/>
@@ -18811,8 +18811,8 @@
         </p:nvSpPr>
         <p:spPr>
           <a:xfrm>
-            <a:off x="7863840" y="1737360"/>
-            <a:ext cx="3657600" cy="685800"/>
+            <a:off x="8138159" y="1737360"/>
+            <a:ext cx="3383280" cy="685800"/>
           </a:xfrm>
           <a:prstGeom prst="rect">
             <a:avLst/>
@@ -18857,7 +18857,7 @@
         <p:spPr>
           <a:xfrm>
             <a:off x="640080" y="2423160"/>
-            <a:ext cx="2743200" cy="685800"/>
+            <a:ext cx="3291840" cy="685800"/>
           </a:xfrm>
           <a:prstGeom prst="rect">
             <a:avLst/>
@@ -18901,7 +18901,7 @@
         <p:spPr>
           <a:xfrm>
             <a:off x="749808" y="2423160"/>
-            <a:ext cx="2633472" cy="685800"/>
+            <a:ext cx="3182112" cy="685800"/>
           </a:xfrm>
           <a:prstGeom prst="rect">
             <a:avLst/>
@@ -18932,7 +18932,7 @@
                 </a:solidFill>
                 <a:latin typeface="Calibri"/>
               </a:rPr>
-              <a:t>Sharpe used sqrt(365)</a:t>
+              <a:t>Sharpe with sqrt(365)</a:t>
             </a:r>
           </a:p>
         </p:txBody>
@@ -18945,8 +18945,8 @@
         </p:nvSpPr>
         <p:spPr>
           <a:xfrm>
-            <a:off x="3383280" y="2423160"/>
-            <a:ext cx="4480560" cy="685800"/>
+            <a:off x="3931920" y="2423160"/>
+            <a:ext cx="4206240" cy="685800"/>
           </a:xfrm>
           <a:prstGeom prst="rect">
             <a:avLst/>
@@ -18989,8 +18989,8 @@
         </p:nvSpPr>
         <p:spPr>
           <a:xfrm>
-            <a:off x="3383280" y="2423160"/>
-            <a:ext cx="4480560" cy="685800"/>
+            <a:off x="3931920" y="2423160"/>
+            <a:ext cx="4206240" cy="685800"/>
           </a:xfrm>
           <a:prstGeom prst="rect">
             <a:avLst/>
@@ -19034,8 +19034,8 @@
         </p:nvSpPr>
         <p:spPr>
           <a:xfrm>
-            <a:off x="7863840" y="2423160"/>
-            <a:ext cx="3657600" cy="685800"/>
+            <a:off x="8138159" y="2423160"/>
+            <a:ext cx="3383280" cy="685800"/>
           </a:xfrm>
           <a:prstGeom prst="rect">
             <a:avLst/>
@@ -19078,8 +19078,8 @@
         </p:nvSpPr>
         <p:spPr>
           <a:xfrm>
-            <a:off x="7863840" y="2423160"/>
-            <a:ext cx="3657600" cy="685800"/>
+            <a:off x="8138159" y="2423160"/>
+            <a:ext cx="3383280" cy="685800"/>
           </a:xfrm>
           <a:prstGeom prst="rect">
             <a:avLst/>
@@ -19124,7 +19124,7 @@
         <p:spPr>
           <a:xfrm>
             <a:off x="640080" y="3108960"/>
-            <a:ext cx="2743200" cy="685800"/>
+            <a:ext cx="3291840" cy="685800"/>
           </a:xfrm>
           <a:prstGeom prst="rect">
             <a:avLst/>
@@ -19168,7 +19168,7 @@
         <p:spPr>
           <a:xfrm>
             <a:off x="749808" y="3108960"/>
-            <a:ext cx="2633472" cy="685800"/>
+            <a:ext cx="3182112" cy="685800"/>
           </a:xfrm>
           <a:prstGeom prst="rect">
             <a:avLst/>
@@ -19199,7 +19199,7 @@
                 </a:solidFill>
                 <a:latin typeface="Calibri"/>
               </a:rPr>
-              <a:t>Hold-out not untouched</a:t>
+              <a:t>Exploration on full 2021-26 sample</a:t>
             </a:r>
           </a:p>
         </p:txBody>
@@ -19212,8 +19212,8 @@
         </p:nvSpPr>
         <p:spPr>
           <a:xfrm>
-            <a:off x="3383280" y="3108960"/>
-            <a:ext cx="4480560" cy="685800"/>
+            <a:off x="3931920" y="3108960"/>
+            <a:ext cx="4206240" cy="685800"/>
           </a:xfrm>
           <a:prstGeom prst="rect">
             <a:avLst/>
@@ -19256,8 +19256,8 @@
         </p:nvSpPr>
         <p:spPr>
           <a:xfrm>
-            <a:off x="3383280" y="3108960"/>
-            <a:ext cx="4480560" cy="685800"/>
+            <a:off x="3931920" y="3108960"/>
+            <a:ext cx="4206240" cy="685800"/>
           </a:xfrm>
           <a:prstGeom prst="rect">
             <a:avLst/>
@@ -19301,8 +19301,8 @@
         </p:nvSpPr>
         <p:spPr>
           <a:xfrm>
-            <a:off x="7863840" y="3108960"/>
-            <a:ext cx="3657600" cy="685800"/>
+            <a:off x="8138159" y="3108960"/>
+            <a:ext cx="3383280" cy="685800"/>
           </a:xfrm>
           <a:prstGeom prst="rect">
             <a:avLst/>
@@ -19345,8 +19345,8 @@
         </p:nvSpPr>
         <p:spPr>
           <a:xfrm>
-            <a:off x="7863840" y="3108960"/>
-            <a:ext cx="3657600" cy="685800"/>
+            <a:off x="8138159" y="3108960"/>
+            <a:ext cx="3383280" cy="685800"/>
           </a:xfrm>
           <a:prstGeom prst="rect">
             <a:avLst/>
@@ -19391,7 +19391,7 @@
         <p:spPr>
           <a:xfrm>
             <a:off x="640080" y="3794760"/>
-            <a:ext cx="2743200" cy="685800"/>
+            <a:ext cx="3291840" cy="685800"/>
           </a:xfrm>
           <a:prstGeom prst="rect">
             <a:avLst/>
@@ -19435,7 +19435,7 @@
         <p:spPr>
           <a:xfrm>
             <a:off x="749808" y="3794760"/>
-            <a:ext cx="2633472" cy="685800"/>
+            <a:ext cx="3182112" cy="685800"/>
           </a:xfrm>
           <a:prstGeom prst="rect">
             <a:avLst/>
@@ -19466,7 +19466,7 @@
                 </a:solidFill>
                 <a:latin typeface="Calibri"/>
               </a:rPr>
-              <a:t>Lead with hold-out; add corr</a:t>
+              <a:t>Full sample first; no corr to BTC</a:t>
             </a:r>
           </a:p>
         </p:txBody>
@@ -19479,8 +19479,8 @@
         </p:nvSpPr>
         <p:spPr>
           <a:xfrm>
-            <a:off x="3383280" y="3794760"/>
-            <a:ext cx="4480560" cy="685800"/>
+            <a:off x="3931920" y="3794760"/>
+            <a:ext cx="4206240" cy="685800"/>
           </a:xfrm>
           <a:prstGeom prst="rect">
             <a:avLst/>
@@ -19523,8 +19523,8 @@
         </p:nvSpPr>
         <p:spPr>
           <a:xfrm>
-            <a:off x="3383280" y="3794760"/>
-            <a:ext cx="4480560" cy="685800"/>
+            <a:off x="3931920" y="3794760"/>
+            <a:ext cx="4206240" cy="685800"/>
           </a:xfrm>
           <a:prstGeom prst="rect">
             <a:avLst/>
@@ -19568,8 +19568,8 @@
         </p:nvSpPr>
         <p:spPr>
           <a:xfrm>
-            <a:off x="7863840" y="3794760"/>
-            <a:ext cx="3657600" cy="685800"/>
+            <a:off x="8138159" y="3794760"/>
+            <a:ext cx="3383280" cy="685800"/>
           </a:xfrm>
           <a:prstGeom prst="rect">
             <a:avLst/>
@@ -19612,8 +19612,8 @@
         </p:nvSpPr>
         <p:spPr>
           <a:xfrm>
-            <a:off x="7863840" y="3794760"/>
-            <a:ext cx="3657600" cy="685800"/>
+            <a:off x="8138159" y="3794760"/>
+            <a:ext cx="3383280" cy="685800"/>
           </a:xfrm>
           <a:prstGeom prst="rect">
             <a:avLst/>
@@ -19658,7 +19658,7 @@
         <p:spPr>
           <a:xfrm>
             <a:off x="640080" y="4480560"/>
-            <a:ext cx="2743200" cy="685800"/>
+            <a:ext cx="3291840" cy="685800"/>
           </a:xfrm>
           <a:prstGeom prst="rect">
             <a:avLst/>
@@ -19702,7 +19702,7 @@
         <p:spPr>
           <a:xfrm>
             <a:off x="749808" y="4480560"/>
-            <a:ext cx="2633472" cy="685800"/>
+            <a:ext cx="3182112" cy="685800"/>
           </a:xfrm>
           <a:prstGeom prst="rect">
             <a:avLst/>
@@ -19733,7 +19733,7 @@
                 </a:solidFill>
                 <a:latin typeface="Calibri"/>
               </a:rPr>
-              <a:t>16 survivors</a:t>
+              <a:t>16 coins alive in 2026</a:t>
             </a:r>
           </a:p>
         </p:txBody>
@@ -19746,8 +19746,8 @@
         </p:nvSpPr>
         <p:spPr>
           <a:xfrm>
-            <a:off x="3383280" y="4480560"/>
-            <a:ext cx="4480560" cy="685800"/>
+            <a:off x="3931920" y="4480560"/>
+            <a:ext cx="4206240" cy="685800"/>
           </a:xfrm>
           <a:prstGeom prst="rect">
             <a:avLst/>
@@ -19790,8 +19790,8 @@
         </p:nvSpPr>
         <p:spPr>
           <a:xfrm>
-            <a:off x="3383280" y="4480560"/>
-            <a:ext cx="4480560" cy="685800"/>
+            <a:off x="3931920" y="4480560"/>
+            <a:ext cx="4206240" cy="685800"/>
           </a:xfrm>
           <a:prstGeom prst="rect">
             <a:avLst/>
@@ -19835,8 +19835,8 @@
         </p:nvSpPr>
         <p:spPr>
           <a:xfrm>
-            <a:off x="7863840" y="4480560"/>
-            <a:ext cx="3657600" cy="685800"/>
+            <a:off x="8138159" y="4480560"/>
+            <a:ext cx="3383280" cy="685800"/>
           </a:xfrm>
           <a:prstGeom prst="rect">
             <a:avLst/>
@@ -19879,8 +19879,8 @@
         </p:nvSpPr>
         <p:spPr>
           <a:xfrm>
-            <a:off x="7863840" y="4480560"/>
-            <a:ext cx="3657600" cy="685800"/>
+            <a:off x="8138159" y="4480560"/>
+            <a:ext cx="3383280" cy="685800"/>
           </a:xfrm>
           <a:prstGeom prst="rect">
             <a:avLst/>
@@ -19925,7 +19925,7 @@
         <p:spPr>
           <a:xfrm>
             <a:off x="640080" y="5166360"/>
-            <a:ext cx="2743200" cy="685800"/>
+            <a:ext cx="3291840" cy="685800"/>
           </a:xfrm>
           <a:prstGeom prst="rect">
             <a:avLst/>
@@ -19969,7 +19969,7 @@
         <p:spPr>
           <a:xfrm>
             <a:off x="749808" y="5166360"/>
-            <a:ext cx="2633472" cy="685800"/>
+            <a:ext cx="3182112" cy="685800"/>
           </a:xfrm>
           <a:prstGeom prst="rect">
             <a:avLst/>
@@ -20000,7 +20000,7 @@
                 </a:solidFill>
                 <a:latin typeface="Calibri"/>
               </a:rPr>
-              <a:t>Explain and rebuild</a:t>
+              <a:t>No rebuild or methodology guide</a:t>
             </a:r>
           </a:p>
         </p:txBody>
@@ -20013,8 +20013,8 @@
         </p:nvSpPr>
         <p:spPr>
           <a:xfrm>
-            <a:off x="3383280" y="5166360"/>
-            <a:ext cx="4480560" cy="685800"/>
+            <a:off x="3931920" y="5166360"/>
+            <a:ext cx="4206240" cy="685800"/>
           </a:xfrm>
           <a:prstGeom prst="rect">
             <a:avLst/>
@@ -20057,8 +20057,8 @@
         </p:nvSpPr>
         <p:spPr>
           <a:xfrm>
-            <a:off x="3383280" y="5166360"/>
-            <a:ext cx="4480560" cy="685800"/>
+            <a:off x="3931920" y="5166360"/>
+            <a:ext cx="4206240" cy="685800"/>
           </a:xfrm>
           <a:prstGeom prst="rect">
             <a:avLst/>
@@ -20102,8 +20102,8 @@
         </p:nvSpPr>
         <p:spPr>
           <a:xfrm>
-            <a:off x="7863840" y="5166360"/>
-            <a:ext cx="3657600" cy="685800"/>
+            <a:off x="8138159" y="5166360"/>
+            <a:ext cx="3383280" cy="685800"/>
           </a:xfrm>
           <a:prstGeom prst="rect">
             <a:avLst/>
@@ -20146,8 +20146,8 @@
         </p:nvSpPr>
         <p:spPr>
           <a:xfrm>
-            <a:off x="7863840" y="5166360"/>
-            <a:ext cx="3657600" cy="685800"/>
+            <a:off x="8138159" y="5166360"/>
+            <a:ext cx="3383280" cy="685800"/>
           </a:xfrm>
           <a:prstGeom prst="rect">
             <a:avLst/>

</xml_diff>